<commit_message>
samsung store assets: the exit popup in the App Description deck
The UI-structure diagram, the usage scenario's Return step and a 1.1
revision row describe the 1.1.1 Return behaviour; the PDF is
re-exported from the deck.

Co-Authored-By: Claude Opus 5.5 <noreply@anthropic.com>
</commit_message>
<xml_diff>
--- a/docs/store-assets/samsung-appstore/OnScreen_App_Description.pptx
+++ b/docs/store-assets/samsung-appstore/OnScreen_App_Description.pptx
@@ -17661,6 +17661,92 @@
                   </a:tcPr>
                 </a:tc>
               </a:tr>
+              <a:tr h="330200">
+                <a:tc>
+                  <a:txBody>
+                    <a:bodyPr/>
+                    <a:lstStyle/>
+                    <a:p>
+                      <a:r>
+                        <a:rPr i="0" sz="1200">
+                          <a:solidFill>
+                            <a:srgbClr val="1F2A37"/>
+                          </a:solidFill>
+                        </a:rPr>
+                        <a:t>1.1</a:t>
+                      </a:r>
+                    </a:p>
+                  </a:txBody>
+                  <a:tcPr marL="38100" marR="38100" marT="19050" marB="19050">
+                    <a:solidFill>
+                      <a:srgbClr val="FFFFFF"/>
+                    </a:solidFill>
+                  </a:tcPr>
+                </a:tc>
+                <a:tc>
+                  <a:txBody>
+                    <a:bodyPr/>
+                    <a:lstStyle/>
+                    <a:p>
+                      <a:r>
+                        <a:rPr i="0" sz="1200">
+                          <a:solidFill>
+                            <a:srgbClr val="1F2A37"/>
+                          </a:solidFill>
+                        </a:rPr>
+                        <a:t>2026.10.19</a:t>
+                      </a:r>
+                    </a:p>
+                  </a:txBody>
+                  <a:tcPr marL="38100" marR="38100" marT="19050" marB="19050">
+                    <a:solidFill>
+                      <a:srgbClr val="FFFFFF"/>
+                    </a:solidFill>
+                  </a:tcPr>
+                </a:tc>
+                <a:tc>
+                  <a:txBody>
+                    <a:bodyPr/>
+                    <a:lstStyle/>
+                    <a:p>
+                      <a:r>
+                        <a:rPr i="0" sz="1200">
+                          <a:solidFill>
+                            <a:srgbClr val="1F2A37"/>
+                          </a:solidFill>
+                        </a:rPr>
+                        <a:t>App version 1.1.1 for the resubmission: RETURN on the first screen opens an "Exit OnScreen?" confirmation popup (Return Key Policy). UI structure and usage scenario updated.</a:t>
+                      </a:r>
+                    </a:p>
+                  </a:txBody>
+                  <a:tcPr marL="38100" marR="38100" marT="19050" marB="19050">
+                    <a:solidFill>
+                      <a:srgbClr val="FFFFFF"/>
+                    </a:solidFill>
+                  </a:tcPr>
+                </a:tc>
+                <a:tc>
+                  <a:txBody>
+                    <a:bodyPr/>
+                    <a:lstStyle/>
+                    <a:p>
+                      <a:r>
+                        <a:rPr i="0" sz="1200">
+                          <a:solidFill>
+                            <a:srgbClr val="1F2A37"/>
+                          </a:solidFill>
+                        </a:rPr>
+                        <a:t>Collin Aycock</a:t>
+                      </a:r>
+                    </a:p>
+                  </a:txBody>
+                  <a:tcPr marL="38100" marR="38100" marT="19050" marB="19050">
+                    <a:solidFill>
+                      <a:srgbClr val="FFFFFF"/>
+                    </a:solidFill>
+                  </a:tcPr>
+                </a:tc>
+              </a:tr>
             </a:tbl>
           </a:graphicData>
         </a:graphic>
@@ -18835,7 +18921,7 @@
                   <a:srgbClr val="1F2A37"/>
                 </a:solidFill>
               </a:rPr>
-              <a:t>4. RETURN goes back to the detail page, and again to Home. RETURN on Home closes the app (Smart Hub). EXIT closes the app from anywhere.</a:t>
+              <a:t>4. RETURN goes back to the detail page, and again to Home. RETURN on Home opens the "Exit OnScreen?" popup: Exit closes the app (Smart Hub), Cancel stays. EXIT closes the app from anywhere.</a:t>
             </a:r>
           </a:p>
           <a:p>

</xml_diff>